<commit_message>
Update inferential statistics workshop with new exercises and detailed explanations
</commit_message>
<xml_diff>
--- a/Semana_6/Semana_6_01_Conceptos_basicos_estadistica_inferencial/01_Estadistica_inferencial_conceptos.pptx
+++ b/Semana_6/Semana_6_01_Conceptos_basicos_estadistica_inferencial/01_Estadistica_inferencial_conceptos.pptx
@@ -12,11 +12,17 @@
     <p:sldId id="341" r:id="rId3"/>
     <p:sldId id="342" r:id="rId4"/>
     <p:sldId id="333" r:id="rId5"/>
+    <p:sldId id="348" r:id="rId18"/>
     <p:sldId id="343" r:id="rId6"/>
+    <p:sldId id="349" r:id="rId19"/>
     <p:sldId id="344" r:id="rId7"/>
+    <p:sldId id="350" r:id="rId20"/>
     <p:sldId id="345" r:id="rId8"/>
+    <p:sldId id="351" r:id="rId21"/>
     <p:sldId id="346" r:id="rId9"/>
+    <p:sldId id="352" r:id="rId22"/>
     <p:sldId id="347" r:id="rId10"/>
+    <p:sldId id="353" r:id="rId23"/>
     <p:sldId id="340" r:id="rId11"/>
   </p:sldIdLst>
   <p:sldSz cx="12192000" cy="6858000"/>
@@ -7321,6 +7327,1194 @@
     <p:extLst>
       <p:ext uri="{BB962C8B-B14F-4D97-AF65-F5344CB8AC3E}">
         <p14:creationId xmlns:p14="http://schemas.microsoft.com/office/powerpoint/2010/main" val="2695536683"/>
+      </p:ext>
+    </p:extLst>
+  </p:cSld>
+  <p:clrMapOvr>
+    <a:masterClrMapping/>
+  </p:clrMapOvr>
+</p:sld>
+</file>
+
+<file path=ppt/slides/slide10.xml><?xml version="1.0" encoding="utf-8"?>
+<p:sld xmlns:a="http://schemas.openxmlformats.org/drawingml/2006/main" xmlns:r="http://schemas.openxmlformats.org/officeDocument/2006/relationships" xmlns:p="http://schemas.openxmlformats.org/presentationml/2006/main">
+  <p:cSld>
+    <p:spTree>
+      <p:nvGrpSpPr>
+        <p:cNvPr id="1" name=""/>
+        <p:cNvGrpSpPr/>
+        <p:nvPr/>
+      </p:nvGrpSpPr>
+      <p:grpSpPr>
+        <a:xfrm>
+          <a:off x="0" y="0"/>
+          <a:ext cx="0" cy="0"/>
+          <a:chOff x="0" y="0"/>
+          <a:chExt cx="0" cy="0"/>
+        </a:xfrm>
+      </p:grpSpPr>
+      <p:sp>
+        <p:nvSpPr>
+          <p:cNvPr id="4" name="Título 1">
+            <a:extLst>
+              <a:ext uri="{FF2B5EF4-FFF2-40B4-BE49-F238E27FC236}">
+                <a16:creationId xmlns:a16="http://schemas.microsoft.com/office/drawing/2014/main" id="{0F6B7236-ADCC-D13A-7C6C-1B5FEAEF1816}"/>
+              </a:ext>
+            </a:extLst>
+          </p:cNvPr>
+          <p:cNvSpPr>
+            <a:spLocks noGrp="1"/>
+          </p:cNvSpPr>
+          <p:nvPr>
+            <p:ph type="title"/>
+          </p:nvPr>
+        </p:nvSpPr>
+        <p:spPr>
+          <a:xfrm>
+            <a:off x="390727" y="-218534"/>
+            <a:ext cx="10515600" cy="1325563"/>
+          </a:xfrm>
+          <a:prstGeom prst="rect">
+            <a:avLst/>
+          </a:prstGeom>
+        </p:spPr>
+        <p:txBody>
+          <a:bodyPr vert="horz" lIns="91440" tIns="45720" rIns="91440" bIns="45720" rtlCol="0" anchor="ctr">
+            <a:normAutofit/>
+          </a:bodyPr>
+          <a:lstStyle>
+            <a:lvl1pPr algn="l" defTabSz="914400" rtl="0" eaLnBrk="1" latinLnBrk="0" hangingPunct="1">
+              <a:lnSpc>
+                <a:spcPct val="90000"/>
+              </a:lnSpc>
+              <a:spcBef>
+                <a:spcPct val="0"/>
+              </a:spcBef>
+              <a:buNone/>
+              <a:defRPr sz="4400" kern="1200">
+                <a:solidFill>
+                  <a:schemeClr val="tx1"/>
+                </a:solidFill>
+                <a:latin typeface="+mj-lt"/>
+                <a:ea typeface="+mj-ea"/>
+                <a:cs typeface="+mj-cs"/>
+              </a:defRPr>
+            </a:lvl1pPr>
+          </a:lstStyle>
+          <a:p>
+            <a:r>
+              <a:rPr lang="es-ES" b="1" dirty="0">
+                <a:solidFill>
+                  <a:schemeClr val="bg1"/>
+                </a:solidFill>
+              </a:rPr>
+              <a:t>Ejercicio: descriptiva vs. inferencial</a:t>
+            </a:r>
+            <a:endParaRPr lang="es-CO" b="1" dirty="0">
+              <a:solidFill>
+                <a:schemeClr val="bg1"/>
+              </a:solidFill>
+            </a:endParaRPr>
+          </a:p>
+        </p:txBody>
+      </p:sp>
+      <p:sp>
+        <p:nvSpPr>
+          <p:cNvPr id="5" name="CuadroTexto 4"/>
+          <p:cNvSpPr txBox="1"/>
+          <p:nvPr/>
+        </p:nvSpPr>
+        <p:spPr>
+          <a:xfrm>
+            <a:off x="838200" y="1450000"/>
+            <a:ext cx="10515600" cy="5100000"/>
+          </a:xfrm>
+          <a:prstGeom prst="rect">
+            <a:avLst/>
+          </a:prstGeom>
+          <a:noFill/>
+        </p:spPr>
+        <p:txBody>
+          <a:bodyPr wrap="square" lIns="91440" tIns="45720" rIns="91440" bIns="45720" anchor="t">
+            <a:normAutofit/>
+          </a:bodyPr>
+          <a:lstStyle/>
+          <a:p>
+            <a:pPr marL="285750" indent="-285750">
+              <a:lnSpc>
+                <a:spcPct val="115000"/>
+              </a:lnSpc>
+              <a:spcAft>
+                <a:spcPts val="1800"/>
+              </a:spcAft>
+              <a:buFont typeface="Arial"/>
+              <a:buChar char="•"/>
+            </a:pPr>
+            <a:r>
+              <a:rPr lang="es-CO" sz="1700" b="1" dirty="0"/>
+              <a:t>Situación: </a:t>
+            </a:r>
+            <a:r>
+              <a:rPr lang="es-CO" sz="1700" dirty="0"/>
+              <a:t>642 estudiantes sin curso promedian 64.08 en matemáticas; 358 con curso promedian 69.70.</a:t>
+            </a:r>
+          </a:p>
+          <a:p>
+            <a:pPr marL="285750" indent="-285750">
+              <a:lnSpc>
+                <a:spcPct val="115000"/>
+              </a:lnSpc>
+              <a:spcAft>
+                <a:spcPts val="1800"/>
+              </a:spcAft>
+              <a:buFont typeface="Arial"/>
+              <a:buChar char="•"/>
+            </a:pPr>
+            <a:r>
+              <a:rPr lang="es-CO" sz="1700" b="1" dirty="0"/>
+              <a:t>Pregunta: </a:t>
+            </a:r>
+            <a:r>
+              <a:rPr lang="es-CO" sz="1700" dirty="0"/>
+              <a:t>¿la frase “el curso mejora el promedio de TODOS los estudiantes que presentan el examen” es descriptiva o inferencial?</a:t>
+            </a:r>
+          </a:p>
+          <a:p>
+            <a:pPr marL="285750" indent="-285750">
+              <a:lnSpc>
+                <a:spcPct val="115000"/>
+              </a:lnSpc>
+              <a:spcAft>
+                <a:spcPts val="1800"/>
+              </a:spcAft>
+              <a:buFont typeface="Arial"/>
+              <a:buChar char="•"/>
+            </a:pPr>
+            <a:r>
+              <a:rPr lang="es-CO" sz="1700" b="1" dirty="0"/>
+              <a:t>Respuesta: </a:t>
+            </a:r>
+            <a:r>
+              <a:rPr lang="es-CO" sz="1700" i="1" dirty="0"/>
+              <a:t>es inferencial: generaliza más allá de los 1000 estudiantes de la muestra hacia toda la población.</a:t>
+            </a:r>
+          </a:p>
+          <a:p>
+            <a:pPr marL="285750" indent="-285750">
+              <a:lnSpc>
+                <a:spcPct val="115000"/>
+              </a:lnSpc>
+              <a:spcAft>
+                <a:spcPts val="1800"/>
+              </a:spcAft>
+              <a:buFont typeface="Arial"/>
+              <a:buChar char="•"/>
+            </a:pPr>
+            <a:r>
+              <a:rPr lang="es-CO" sz="1700" b="1" dirty="0"/>
+              <a:t>¿Por qué importa?: </a:t>
+            </a:r>
+            <a:r>
+              <a:rPr lang="es-CO" sz="1700" dirty="0"/>
+              <a:t>ver una diferencia en la muestra no basta; hace falta una prueba de hipótesis para saber si es real o azar.</a:t>
+            </a:r>
+          </a:p>
+        </p:txBody>
+      </p:sp>
+    </p:spTree>
+    <p:extLst>
+      <p:ext uri="{BB962C8B-B14F-4D97-AF65-F5344CB8AC3E}">
+        <p14:creationId xmlns:p14="http://schemas.microsoft.com/office/powerpoint/2010/main" val="1699772436"/>
+      </p:ext>
+    </p:extLst>
+  </p:cSld>
+  <p:clrMapOvr>
+    <a:masterClrMapping/>
+  </p:clrMapOvr>
+</p:sld>
+</file>
+
+<file path=ppt/slides/slide11.xml><?xml version="1.0" encoding="utf-8"?>
+<p:sld xmlns:a="http://schemas.openxmlformats.org/drawingml/2006/main" xmlns:r="http://schemas.openxmlformats.org/officeDocument/2006/relationships" xmlns:p="http://schemas.openxmlformats.org/presentationml/2006/main">
+  <p:cSld>
+    <p:spTree>
+      <p:nvGrpSpPr>
+        <p:cNvPr id="1" name=""/>
+        <p:cNvGrpSpPr/>
+        <p:nvPr/>
+      </p:nvGrpSpPr>
+      <p:grpSpPr>
+        <a:xfrm>
+          <a:off x="0" y="0"/>
+          <a:ext cx="0" cy="0"/>
+          <a:chOff x="0" y="0"/>
+          <a:chExt cx="0" cy="0"/>
+        </a:xfrm>
+      </p:grpSpPr>
+      <p:sp>
+        <p:nvSpPr>
+          <p:cNvPr id="4" name="Título 1">
+            <a:extLst>
+              <a:ext uri="{FF2B5EF4-FFF2-40B4-BE49-F238E27FC236}">
+                <a16:creationId xmlns:a16="http://schemas.microsoft.com/office/drawing/2014/main" id="{0F6B7236-ADCC-D13A-7C6C-1B5FEAEF1816}"/>
+              </a:ext>
+            </a:extLst>
+          </p:cNvPr>
+          <p:cNvSpPr>
+            <a:spLocks noGrp="1"/>
+          </p:cNvSpPr>
+          <p:nvPr>
+            <p:ph type="title"/>
+          </p:nvPr>
+        </p:nvSpPr>
+        <p:spPr>
+          <a:xfrm>
+            <a:off x="390727" y="-218534"/>
+            <a:ext cx="10515600" cy="1325563"/>
+          </a:xfrm>
+          <a:prstGeom prst="rect">
+            <a:avLst/>
+          </a:prstGeom>
+        </p:spPr>
+        <p:txBody>
+          <a:bodyPr vert="horz" lIns="91440" tIns="45720" rIns="91440" bIns="45720" rtlCol="0" anchor="ctr">
+            <a:normAutofit/>
+          </a:bodyPr>
+          <a:lstStyle>
+            <a:lvl1pPr algn="l" defTabSz="914400" rtl="0" eaLnBrk="1" latinLnBrk="0" hangingPunct="1">
+              <a:lnSpc>
+                <a:spcPct val="90000"/>
+              </a:lnSpc>
+              <a:spcBef>
+                <a:spcPct val="0"/>
+              </a:spcBef>
+              <a:buNone/>
+              <a:defRPr sz="4400" kern="1200">
+                <a:solidFill>
+                  <a:schemeClr val="tx1"/>
+                </a:solidFill>
+                <a:latin typeface="+mj-lt"/>
+                <a:ea typeface="+mj-ea"/>
+                <a:cs typeface="+mj-cs"/>
+              </a:defRPr>
+            </a:lvl1pPr>
+          </a:lstStyle>
+          <a:p>
+            <a:r>
+              <a:rPr lang="es-ES" b="1" dirty="0">
+                <a:solidFill>
+                  <a:schemeClr val="bg1"/>
+                </a:solidFill>
+              </a:rPr>
+              <a:t>Ejercicio: población, muestra y variables</a:t>
+            </a:r>
+            <a:endParaRPr lang="es-CO" b="1" dirty="0">
+              <a:solidFill>
+                <a:schemeClr val="bg1"/>
+              </a:solidFill>
+            </a:endParaRPr>
+          </a:p>
+        </p:txBody>
+      </p:sp>
+      <p:sp>
+        <p:nvSpPr>
+          <p:cNvPr id="5" name="CuadroTexto 4"/>
+          <p:cNvSpPr txBox="1"/>
+          <p:nvPr/>
+        </p:nvSpPr>
+        <p:spPr>
+          <a:xfrm>
+            <a:off x="838200" y="1450000"/>
+            <a:ext cx="10515600" cy="5100000"/>
+          </a:xfrm>
+          <a:prstGeom prst="rect">
+            <a:avLst/>
+          </a:prstGeom>
+          <a:noFill/>
+        </p:spPr>
+        <p:txBody>
+          <a:bodyPr wrap="square" lIns="91440" tIns="45720" rIns="91440" bIns="45720" anchor="t">
+            <a:normAutofit/>
+          </a:bodyPr>
+          <a:lstStyle/>
+          <a:p>
+            <a:pPr marL="285750" indent="-285750">
+              <a:lnSpc>
+                <a:spcPct val="115000"/>
+              </a:lnSpc>
+              <a:spcAft>
+                <a:spcPts val="1800"/>
+              </a:spcAft>
+              <a:buFont typeface="Arial"/>
+              <a:buChar char="•"/>
+            </a:pPr>
+            <a:r>
+              <a:rPr lang="es-CO" sz="1700" b="1" dirty="0"/>
+              <a:t>Situación: </a:t>
+            </a:r>
+            <a:r>
+              <a:rPr lang="es-CO" sz="1700" dirty="0"/>
+              <a:t>el grupo “master's degree” en nivel educativo de los padres tiene solo 59 estudiantes, frente a 226 en “some college”.</a:t>
+            </a:r>
+          </a:p>
+          <a:p>
+            <a:pPr marL="285750" indent="-285750">
+              <a:lnSpc>
+                <a:spcPct val="115000"/>
+              </a:lnSpc>
+              <a:spcAft>
+                <a:spcPts val="1800"/>
+              </a:spcAft>
+              <a:buFont typeface="Arial"/>
+              <a:buChar char="•"/>
+            </a:pPr>
+            <a:r>
+              <a:rPr lang="es-CO" sz="1700" b="1" dirty="0"/>
+              <a:t>Pregunta: </a:t>
+            </a:r>
+            <a:r>
+              <a:rPr lang="es-CO" sz="1700" dirty="0"/>
+              <a:t>¿por qué ese grupo pequeño da una idea menos confiable de su promedio? Y en “¿lunch se relaciona con writing score?”, ¿cuál es la dependiente y cuál la independiente?</a:t>
+            </a:r>
+          </a:p>
+          <a:p>
+            <a:pPr marL="285750" indent="-285750">
+              <a:lnSpc>
+                <a:spcPct val="115000"/>
+              </a:lnSpc>
+              <a:spcAft>
+                <a:spcPts val="1800"/>
+              </a:spcAft>
+              <a:buFont typeface="Arial"/>
+              <a:buChar char="•"/>
+            </a:pPr>
+            <a:r>
+              <a:rPr lang="es-CO" sz="1700" b="1" dirty="0"/>
+              <a:t>Respuesta: </a:t>
+            </a:r>
+            <a:r>
+              <a:rPr lang="es-CO" sz="1700" i="1" dirty="0"/>
+              <a:t>con menos datos, un solo caso atípico pesa más en el promedio. Dependiente: writing score; independiente: lunch.</a:t>
+            </a:r>
+          </a:p>
+          <a:p>
+            <a:pPr marL="285750" indent="-285750">
+              <a:lnSpc>
+                <a:spcPct val="115000"/>
+              </a:lnSpc>
+              <a:spcAft>
+                <a:spcPts val="1800"/>
+              </a:spcAft>
+              <a:buFont typeface="Arial"/>
+              <a:buChar char="•"/>
+            </a:pPr>
+            <a:r>
+              <a:rPr lang="es-CO" sz="1700" b="1" dirty="0"/>
+              <a:t>¿Por qué importa?: </a:t>
+            </a:r>
+            <a:r>
+              <a:rPr lang="es-CO" sz="1700" dirty="0"/>
+              <a:t>identificar bien la muestra y las variables es el primer paso antes de plantear cualquier hipótesis.</a:t>
+            </a:r>
+          </a:p>
+        </p:txBody>
+      </p:sp>
+    </p:spTree>
+    <p:extLst>
+      <p:ext uri="{BB962C8B-B14F-4D97-AF65-F5344CB8AC3E}">
+        <p14:creationId xmlns:p14="http://schemas.microsoft.com/office/powerpoint/2010/main" val="1699772436"/>
+      </p:ext>
+    </p:extLst>
+  </p:cSld>
+  <p:clrMapOvr>
+    <a:masterClrMapping/>
+  </p:clrMapOvr>
+</p:sld>
+</file>
+
+<file path=ppt/slides/slide12.xml><?xml version="1.0" encoding="utf-8"?>
+<p:sld xmlns:a="http://schemas.openxmlformats.org/drawingml/2006/main" xmlns:r="http://schemas.openxmlformats.org/officeDocument/2006/relationships" xmlns:p="http://schemas.openxmlformats.org/presentationml/2006/main">
+  <p:cSld>
+    <p:spTree>
+      <p:nvGrpSpPr>
+        <p:cNvPr id="1" name=""/>
+        <p:cNvGrpSpPr/>
+        <p:nvPr/>
+      </p:nvGrpSpPr>
+      <p:grpSpPr>
+        <a:xfrm>
+          <a:off x="0" y="0"/>
+          <a:ext cx="0" cy="0"/>
+          <a:chOff x="0" y="0"/>
+          <a:chExt cx="0" cy="0"/>
+        </a:xfrm>
+      </p:grpSpPr>
+      <p:sp>
+        <p:nvSpPr>
+          <p:cNvPr id="4" name="Título 1">
+            <a:extLst>
+              <a:ext uri="{FF2B5EF4-FFF2-40B4-BE49-F238E27FC236}">
+                <a16:creationId xmlns:a16="http://schemas.microsoft.com/office/drawing/2014/main" id="{0F6B7236-ADCC-D13A-7C6C-1B5FEAEF1816}"/>
+              </a:ext>
+            </a:extLst>
+          </p:cNvPr>
+          <p:cNvSpPr>
+            <a:spLocks noGrp="1"/>
+          </p:cNvSpPr>
+          <p:nvPr>
+            <p:ph type="title"/>
+          </p:nvPr>
+        </p:nvSpPr>
+        <p:spPr>
+          <a:xfrm>
+            <a:off x="390727" y="-218534"/>
+            <a:ext cx="10515600" cy="1325563"/>
+          </a:xfrm>
+          <a:prstGeom prst="rect">
+            <a:avLst/>
+          </a:prstGeom>
+        </p:spPr>
+        <p:txBody>
+          <a:bodyPr vert="horz" lIns="91440" tIns="45720" rIns="91440" bIns="45720" rtlCol="0" anchor="ctr">
+            <a:normAutofit/>
+          </a:bodyPr>
+          <a:lstStyle>
+            <a:lvl1pPr algn="l" defTabSz="914400" rtl="0" eaLnBrk="1" latinLnBrk="0" hangingPunct="1">
+              <a:lnSpc>
+                <a:spcPct val="90000"/>
+              </a:lnSpc>
+              <a:spcBef>
+                <a:spcPct val="0"/>
+              </a:spcBef>
+              <a:buNone/>
+              <a:defRPr sz="4400" kern="1200">
+                <a:solidFill>
+                  <a:schemeClr val="tx1"/>
+                </a:solidFill>
+                <a:latin typeface="+mj-lt"/>
+                <a:ea typeface="+mj-ea"/>
+                <a:cs typeface="+mj-cs"/>
+              </a:defRPr>
+            </a:lvl1pPr>
+          </a:lstStyle>
+          <a:p>
+            <a:r>
+              <a:rPr lang="es-ES" b="1" dirty="0">
+                <a:solidFill>
+                  <a:schemeClr val="bg1"/>
+                </a:solidFill>
+              </a:rPr>
+              <a:t>Ejercicio: plantear H0 y H1</a:t>
+            </a:r>
+            <a:endParaRPr lang="es-CO" b="1" dirty="0">
+              <a:solidFill>
+                <a:schemeClr val="bg1"/>
+              </a:solidFill>
+            </a:endParaRPr>
+          </a:p>
+        </p:txBody>
+      </p:sp>
+      <p:sp>
+        <p:nvSpPr>
+          <p:cNvPr id="5" name="CuadroTexto 4"/>
+          <p:cNvSpPr txBox="1"/>
+          <p:nvPr/>
+        </p:nvSpPr>
+        <p:spPr>
+          <a:xfrm>
+            <a:off x="838200" y="1450000"/>
+            <a:ext cx="10515600" cy="5100000"/>
+          </a:xfrm>
+          <a:prstGeom prst="rect">
+            <a:avLst/>
+          </a:prstGeom>
+          <a:noFill/>
+        </p:spPr>
+        <p:txBody>
+          <a:bodyPr wrap="square" lIns="91440" tIns="45720" rIns="91440" bIns="45720" anchor="t">
+            <a:normAutofit/>
+          </a:bodyPr>
+          <a:lstStyle/>
+          <a:p>
+            <a:pPr marL="285750" indent="-285750">
+              <a:lnSpc>
+                <a:spcPct val="115000"/>
+              </a:lnSpc>
+              <a:spcAft>
+                <a:spcPts val="1800"/>
+              </a:spcAft>
+              <a:buFont typeface="Arial"/>
+              <a:buChar char="•"/>
+            </a:pPr>
+            <a:r>
+              <a:rPr lang="es-CO" sz="1700" b="1" dirty="0"/>
+              <a:t>Situación: </a:t>
+            </a:r>
+            <a:r>
+              <a:rPr lang="es-CO" sz="1700" dirty="0"/>
+              <a:t>quieres saber si el tipo de almuerzo (lunch: standard vs. free/reduced) se relaciona con el puntaje de escritura.</a:t>
+            </a:r>
+          </a:p>
+          <a:p>
+            <a:pPr marL="285750" indent="-285750">
+              <a:lnSpc>
+                <a:spcPct val="115000"/>
+              </a:lnSpc>
+              <a:spcAft>
+                <a:spcPts val="1800"/>
+              </a:spcAft>
+              <a:buFont typeface="Arial"/>
+              <a:buChar char="•"/>
+            </a:pPr>
+            <a:r>
+              <a:rPr lang="es-CO" sz="1700" b="1" dirty="0"/>
+              <a:t>Pregunta: </a:t>
+            </a:r>
+            <a:r>
+              <a:rPr lang="es-CO" sz="1700" dirty="0"/>
+              <a:t>escribe H0 y H1 para esta comparación.</a:t>
+            </a:r>
+          </a:p>
+          <a:p>
+            <a:pPr marL="285750" indent="-285750">
+              <a:lnSpc>
+                <a:spcPct val="115000"/>
+              </a:lnSpc>
+              <a:spcAft>
+                <a:spcPts val="1800"/>
+              </a:spcAft>
+              <a:buFont typeface="Arial"/>
+              <a:buChar char="•"/>
+            </a:pPr>
+            <a:r>
+              <a:rPr lang="es-CO" sz="1700" b="1" dirty="0"/>
+              <a:t>Respuesta: </a:t>
+            </a:r>
+            <a:r>
+              <a:rPr lang="es-CO" sz="1700" i="1" dirty="0"/>
+              <a:t>H0: los dos grupos tienen el mismo promedio. H1: el promedio sí difiere según el almuerzo (dato real: 70.82 vs. 63.02).</a:t>
+            </a:r>
+          </a:p>
+          <a:p>
+            <a:pPr marL="285750" indent="-285750">
+              <a:lnSpc>
+                <a:spcPct val="115000"/>
+              </a:lnSpc>
+              <a:spcAft>
+                <a:spcPts val="1800"/>
+              </a:spcAft>
+              <a:buFont typeface="Arial"/>
+              <a:buChar char="•"/>
+            </a:pPr>
+            <a:r>
+              <a:rPr lang="es-CO" sz="1700" b="1" dirty="0"/>
+              <a:t>¿Por qué importa?: </a:t>
+            </a:r>
+            <a:r>
+              <a:rPr lang="es-CO" sz="1700" dirty="0"/>
+              <a:t>toda prueba de hipótesis arranca planteando estas dos apuestas antes de calcular nada.</a:t>
+            </a:r>
+          </a:p>
+        </p:txBody>
+      </p:sp>
+    </p:spTree>
+    <p:extLst>
+      <p:ext uri="{BB962C8B-B14F-4D97-AF65-F5344CB8AC3E}">
+        <p14:creationId xmlns:p14="http://schemas.microsoft.com/office/powerpoint/2010/main" val="1699772436"/>
+      </p:ext>
+    </p:extLst>
+  </p:cSld>
+  <p:clrMapOvr>
+    <a:masterClrMapping/>
+  </p:clrMapOvr>
+</p:sld>
+</file>
+
+<file path=ppt/slides/slide13.xml><?xml version="1.0" encoding="utf-8"?>
+<p:sld xmlns:a="http://schemas.openxmlformats.org/drawingml/2006/main" xmlns:r="http://schemas.openxmlformats.org/officeDocument/2006/relationships" xmlns:p="http://schemas.openxmlformats.org/presentationml/2006/main">
+  <p:cSld>
+    <p:spTree>
+      <p:nvGrpSpPr>
+        <p:cNvPr id="1" name=""/>
+        <p:cNvGrpSpPr/>
+        <p:nvPr/>
+      </p:nvGrpSpPr>
+      <p:grpSpPr>
+        <a:xfrm>
+          <a:off x="0" y="0"/>
+          <a:ext cx="0" cy="0"/>
+          <a:chOff x="0" y="0"/>
+          <a:chExt cx="0" cy="0"/>
+        </a:xfrm>
+      </p:grpSpPr>
+      <p:sp>
+        <p:nvSpPr>
+          <p:cNvPr id="4" name="Título 1">
+            <a:extLst>
+              <a:ext uri="{FF2B5EF4-FFF2-40B4-BE49-F238E27FC236}">
+                <a16:creationId xmlns:a16="http://schemas.microsoft.com/office/drawing/2014/main" id="{0F6B7236-ADCC-D13A-7C6C-1B5FEAEF1816}"/>
+              </a:ext>
+            </a:extLst>
+          </p:cNvPr>
+          <p:cNvSpPr>
+            <a:spLocks noGrp="1"/>
+          </p:cNvSpPr>
+          <p:nvPr>
+            <p:ph type="title"/>
+          </p:nvPr>
+        </p:nvSpPr>
+        <p:spPr>
+          <a:xfrm>
+            <a:off x="390727" y="-218534"/>
+            <a:ext cx="10515600" cy="1325563"/>
+          </a:xfrm>
+          <a:prstGeom prst="rect">
+            <a:avLst/>
+          </a:prstGeom>
+        </p:spPr>
+        <p:txBody>
+          <a:bodyPr vert="horz" lIns="91440" tIns="45720" rIns="91440" bIns="45720" rtlCol="0" anchor="ctr">
+            <a:normAutofit/>
+          </a:bodyPr>
+          <a:lstStyle>
+            <a:lvl1pPr algn="l" defTabSz="914400" rtl="0" eaLnBrk="1" latinLnBrk="0" hangingPunct="1">
+              <a:lnSpc>
+                <a:spcPct val="90000"/>
+              </a:lnSpc>
+              <a:spcBef>
+                <a:spcPct val="0"/>
+              </a:spcBef>
+              <a:buNone/>
+              <a:defRPr sz="4400" kern="1200">
+                <a:solidFill>
+                  <a:schemeClr val="tx1"/>
+                </a:solidFill>
+                <a:latin typeface="+mj-lt"/>
+                <a:ea typeface="+mj-ea"/>
+                <a:cs typeface="+mj-cs"/>
+              </a:defRPr>
+            </a:lvl1pPr>
+          </a:lstStyle>
+          <a:p>
+            <a:r>
+              <a:rPr lang="es-ES" b="1" dirty="0">
+                <a:solidFill>
+                  <a:schemeClr val="bg1"/>
+                </a:solidFill>
+              </a:rPr>
+              <a:t>Ejercicio: interpretar el p-value</a:t>
+            </a:r>
+            <a:endParaRPr lang="es-CO" b="1" dirty="0">
+              <a:solidFill>
+                <a:schemeClr val="bg1"/>
+              </a:solidFill>
+            </a:endParaRPr>
+          </a:p>
+        </p:txBody>
+      </p:sp>
+      <p:sp>
+        <p:nvSpPr>
+          <p:cNvPr id="5" name="CuadroTexto 4"/>
+          <p:cNvSpPr txBox="1"/>
+          <p:nvPr/>
+        </p:nvSpPr>
+        <p:spPr>
+          <a:xfrm>
+            <a:off x="838200" y="1450000"/>
+            <a:ext cx="10515600" cy="5100000"/>
+          </a:xfrm>
+          <a:prstGeom prst="rect">
+            <a:avLst/>
+          </a:prstGeom>
+          <a:noFill/>
+        </p:spPr>
+        <p:txBody>
+          <a:bodyPr wrap="square" lIns="91440" tIns="45720" rIns="91440" bIns="45720" anchor="t">
+            <a:normAutofit/>
+          </a:bodyPr>
+          <a:lstStyle/>
+          <a:p>
+            <a:pPr marL="285750" indent="-285750">
+              <a:lnSpc>
+                <a:spcPct val="115000"/>
+              </a:lnSpc>
+              <a:spcAft>
+                <a:spcPts val="1800"/>
+              </a:spcAft>
+              <a:buFont typeface="Arial"/>
+              <a:buChar char="•"/>
+            </a:pPr>
+            <a:r>
+              <a:rPr lang="es-CO" sz="1700" b="1" dirty="0"/>
+              <a:t>Situación: </a:t>
+            </a:r>
+            <a:r>
+              <a:rPr lang="es-CO" sz="1700" dirty="0"/>
+              <a:t>al comparar el puntaje de matemáticas entre grupos de curso de preparación, el p-value da 0.00000008.</a:t>
+            </a:r>
+          </a:p>
+          <a:p>
+            <a:pPr marL="285750" indent="-285750">
+              <a:lnSpc>
+                <a:spcPct val="115000"/>
+              </a:lnSpc>
+              <a:spcAft>
+                <a:spcPts val="1800"/>
+              </a:spcAft>
+              <a:buFont typeface="Arial"/>
+              <a:buChar char="•"/>
+            </a:pPr>
+            <a:r>
+              <a:rPr lang="es-CO" sz="1700" b="1" dirty="0"/>
+              <a:t>Pregunta: </a:t>
+            </a:r>
+            <a:r>
+              <a:rPr lang="es-CO" sz="1700" dirty="0"/>
+              <a:t>¿ese resultado es chiquito o grande según la regla de 0.05? ¿Le creemos a H0 o a H1?</a:t>
+            </a:r>
+          </a:p>
+          <a:p>
+            <a:pPr marL="285750" indent="-285750">
+              <a:lnSpc>
+                <a:spcPct val="115000"/>
+              </a:lnSpc>
+              <a:spcAft>
+                <a:spcPts val="1800"/>
+              </a:spcAft>
+              <a:buFont typeface="Arial"/>
+              <a:buChar char="•"/>
+            </a:pPr>
+            <a:r>
+              <a:rPr lang="es-CO" sz="1700" b="1" dirty="0"/>
+              <a:t>Respuesta: </a:t>
+            </a:r>
+            <a:r>
+              <a:rPr lang="es-CO" sz="1700" i="1" dirty="0"/>
+              <a:t>es chiquito, muchísimo menor a 0.05 → le creemos a H1, se rechaza H0.</a:t>
+            </a:r>
+          </a:p>
+          <a:p>
+            <a:pPr marL="285750" indent="-285750">
+              <a:lnSpc>
+                <a:spcPct val="115000"/>
+              </a:lnSpc>
+              <a:spcAft>
+                <a:spcPts val="1800"/>
+              </a:spcAft>
+              <a:buFont typeface="Arial"/>
+              <a:buChar char="•"/>
+            </a:pPr>
+            <a:r>
+              <a:rPr lang="es-CO" sz="1700" b="1" dirty="0"/>
+              <a:t>¿Por qué importa?: </a:t>
+            </a:r>
+            <a:r>
+              <a:rPr lang="es-CO" sz="1700" dirty="0"/>
+              <a:t>sería casi imposible ver esa diferencia por pura casualidad si el curso no tuviera ningún efecto.</a:t>
+            </a:r>
+          </a:p>
+        </p:txBody>
+      </p:sp>
+    </p:spTree>
+    <p:extLst>
+      <p:ext uri="{BB962C8B-B14F-4D97-AF65-F5344CB8AC3E}">
+        <p14:creationId xmlns:p14="http://schemas.microsoft.com/office/powerpoint/2010/main" val="1699772436"/>
+      </p:ext>
+    </p:extLst>
+  </p:cSld>
+  <p:clrMapOvr>
+    <a:masterClrMapping/>
+  </p:clrMapOvr>
+</p:sld>
+</file>
+
+<file path=ppt/slides/slide14.xml><?xml version="1.0" encoding="utf-8"?>
+<p:sld xmlns:a="http://schemas.openxmlformats.org/drawingml/2006/main" xmlns:r="http://schemas.openxmlformats.org/officeDocument/2006/relationships" xmlns:p="http://schemas.openxmlformats.org/presentationml/2006/main">
+  <p:cSld>
+    <p:spTree>
+      <p:nvGrpSpPr>
+        <p:cNvPr id="1" name=""/>
+        <p:cNvGrpSpPr/>
+        <p:nvPr/>
+      </p:nvGrpSpPr>
+      <p:grpSpPr>
+        <a:xfrm>
+          <a:off x="0" y="0"/>
+          <a:ext cx="0" cy="0"/>
+          <a:chOff x="0" y="0"/>
+          <a:chExt cx="0" cy="0"/>
+        </a:xfrm>
+      </p:grpSpPr>
+      <p:sp>
+        <p:nvSpPr>
+          <p:cNvPr id="4" name="Título 1">
+            <a:extLst>
+              <a:ext uri="{FF2B5EF4-FFF2-40B4-BE49-F238E27FC236}">
+                <a16:creationId xmlns:a16="http://schemas.microsoft.com/office/drawing/2014/main" id="{0F6B7236-ADCC-D13A-7C6C-1B5FEAEF1816}"/>
+              </a:ext>
+            </a:extLst>
+          </p:cNvPr>
+          <p:cNvSpPr>
+            <a:spLocks noGrp="1"/>
+          </p:cNvSpPr>
+          <p:nvPr>
+            <p:ph type="title"/>
+          </p:nvPr>
+        </p:nvSpPr>
+        <p:spPr>
+          <a:xfrm>
+            <a:off x="390727" y="-218534"/>
+            <a:ext cx="10515600" cy="1325563"/>
+          </a:xfrm>
+          <a:prstGeom prst="rect">
+            <a:avLst/>
+          </a:prstGeom>
+        </p:spPr>
+        <p:txBody>
+          <a:bodyPr vert="horz" lIns="91440" tIns="45720" rIns="91440" bIns="45720" rtlCol="0" anchor="ctr">
+            <a:normAutofit/>
+          </a:bodyPr>
+          <a:lstStyle>
+            <a:lvl1pPr algn="l" defTabSz="914400" rtl="0" eaLnBrk="1" latinLnBrk="0" hangingPunct="1">
+              <a:lnSpc>
+                <a:spcPct val="90000"/>
+              </a:lnSpc>
+              <a:spcBef>
+                <a:spcPct val="0"/>
+              </a:spcBef>
+              <a:buNone/>
+              <a:defRPr sz="4400" kern="1200">
+                <a:solidFill>
+                  <a:schemeClr val="tx1"/>
+                </a:solidFill>
+                <a:latin typeface="+mj-lt"/>
+                <a:ea typeface="+mj-ea"/>
+                <a:cs typeface="+mj-cs"/>
+              </a:defRPr>
+            </a:lvl1pPr>
+          </a:lstStyle>
+          <a:p>
+            <a:r>
+              <a:rPr lang="es-ES" b="1" dirty="0">
+                <a:solidFill>
+                  <a:schemeClr val="bg1"/>
+                </a:solidFill>
+              </a:rPr>
+              <a:t>Ejercicio: errores tipo I y II</a:t>
+            </a:r>
+            <a:endParaRPr lang="es-CO" b="1" dirty="0">
+              <a:solidFill>
+                <a:schemeClr val="bg1"/>
+              </a:solidFill>
+            </a:endParaRPr>
+          </a:p>
+        </p:txBody>
+      </p:sp>
+      <p:sp>
+        <p:nvSpPr>
+          <p:cNvPr id="5" name="CuadroTexto 4"/>
+          <p:cNvSpPr txBox="1"/>
+          <p:nvPr/>
+        </p:nvSpPr>
+        <p:spPr>
+          <a:xfrm>
+            <a:off x="838200" y="1450000"/>
+            <a:ext cx="10515600" cy="5100000"/>
+          </a:xfrm>
+          <a:prstGeom prst="rect">
+            <a:avLst/>
+          </a:prstGeom>
+          <a:noFill/>
+        </p:spPr>
+        <p:txBody>
+          <a:bodyPr wrap="square" lIns="91440" tIns="45720" rIns="91440" bIns="45720" anchor="t">
+            <a:normAutofit/>
+          </a:bodyPr>
+          <a:lstStyle/>
+          <a:p>
+            <a:pPr marL="285750" indent="-285750">
+              <a:lnSpc>
+                <a:spcPct val="115000"/>
+              </a:lnSpc>
+              <a:spcAft>
+                <a:spcPts val="1800"/>
+              </a:spcAft>
+              <a:buFont typeface="Arial"/>
+              <a:buChar char="•"/>
+            </a:pPr>
+            <a:r>
+              <a:rPr lang="es-CO" sz="1700" b="1" dirty="0"/>
+              <a:t>Situación: </a:t>
+            </a:r>
+            <a:r>
+              <a:rPr lang="es-CO" sz="1700" dirty="0"/>
+              <a:t>concluimos “el curso SÍ mejora la nota” cuando en realidad no tiene ningún efecto real en la población.</a:t>
+            </a:r>
+          </a:p>
+          <a:p>
+            <a:pPr marL="285750" indent="-285750">
+              <a:lnSpc>
+                <a:spcPct val="115000"/>
+              </a:lnSpc>
+              <a:spcAft>
+                <a:spcPts val="1800"/>
+              </a:spcAft>
+              <a:buFont typeface="Arial"/>
+              <a:buChar char="•"/>
+            </a:pPr>
+            <a:r>
+              <a:rPr lang="es-CO" sz="1700" b="1" dirty="0"/>
+              <a:t>Pregunta: </a:t>
+            </a:r>
+            <a:r>
+              <a:rPr lang="es-CO" sz="1700" dirty="0"/>
+              <a:t>¿qué tipo de error es este? ¿Y el caso contrario (decir “no hay efecto” cuando sí lo hay)?</a:t>
+            </a:r>
+          </a:p>
+          <a:p>
+            <a:pPr marL="285750" indent="-285750">
+              <a:lnSpc>
+                <a:spcPct val="115000"/>
+              </a:lnSpc>
+              <a:spcAft>
+                <a:spcPts val="1800"/>
+              </a:spcAft>
+              <a:buFont typeface="Arial"/>
+              <a:buChar char="•"/>
+            </a:pPr>
+            <a:r>
+              <a:rPr lang="es-CO" sz="1700" b="1" dirty="0"/>
+              <a:t>Respuesta: </a:t>
+            </a:r>
+            <a:r>
+              <a:rPr lang="es-CO" sz="1700" i="1" dirty="0"/>
+              <a:t>el primero es error tipo I (falsa alarma); el segundo es error tipo II (no darse cuenta).</a:t>
+            </a:r>
+          </a:p>
+          <a:p>
+            <a:pPr marL="285750" indent="-285750">
+              <a:lnSpc>
+                <a:spcPct val="115000"/>
+              </a:lnSpc>
+              <a:spcAft>
+                <a:spcPts val="1800"/>
+              </a:spcAft>
+              <a:buFont typeface="Arial"/>
+              <a:buChar char="•"/>
+            </a:pPr>
+            <a:r>
+              <a:rPr lang="es-CO" sz="1700" b="1" dirty="0"/>
+              <a:t>¿Por qué importa?: </a:t>
+            </a:r>
+            <a:r>
+              <a:rPr lang="es-CO" sz="1700" dirty="0"/>
+              <a:t>con más datos (como nuestros 1000 estudiantes), es menos probable cometer el error tipo II.</a:t>
+            </a:r>
+          </a:p>
+        </p:txBody>
+      </p:sp>
+    </p:spTree>
+    <p:extLst>
+      <p:ext uri="{BB962C8B-B14F-4D97-AF65-F5344CB8AC3E}">
+        <p14:creationId xmlns:p14="http://schemas.microsoft.com/office/powerpoint/2010/main" val="1699772436"/>
+      </p:ext>
+    </p:extLst>
+  </p:cSld>
+  <p:clrMapOvr>
+    <a:masterClrMapping/>
+  </p:clrMapOvr>
+</p:sld>
+</file>
+
+<file path=ppt/slides/slide15.xml><?xml version="1.0" encoding="utf-8"?>
+<p:sld xmlns:a="http://schemas.openxmlformats.org/drawingml/2006/main" xmlns:r="http://schemas.openxmlformats.org/officeDocument/2006/relationships" xmlns:p="http://schemas.openxmlformats.org/presentationml/2006/main">
+  <p:cSld>
+    <p:spTree>
+      <p:nvGrpSpPr>
+        <p:cNvPr id="1" name=""/>
+        <p:cNvGrpSpPr/>
+        <p:nvPr/>
+      </p:nvGrpSpPr>
+      <p:grpSpPr>
+        <a:xfrm>
+          <a:off x="0" y="0"/>
+          <a:ext cx="0" cy="0"/>
+          <a:chOff x="0" y="0"/>
+          <a:chExt cx="0" cy="0"/>
+        </a:xfrm>
+      </p:grpSpPr>
+      <p:sp>
+        <p:nvSpPr>
+          <p:cNvPr id="4" name="Título 1">
+            <a:extLst>
+              <a:ext uri="{FF2B5EF4-FFF2-40B4-BE49-F238E27FC236}">
+                <a16:creationId xmlns:a16="http://schemas.microsoft.com/office/drawing/2014/main" id="{0F6B7236-ADCC-D13A-7C6C-1B5FEAEF1816}"/>
+              </a:ext>
+            </a:extLst>
+          </p:cNvPr>
+          <p:cNvSpPr>
+            <a:spLocks noGrp="1"/>
+          </p:cNvSpPr>
+          <p:nvPr>
+            <p:ph type="title"/>
+          </p:nvPr>
+        </p:nvSpPr>
+        <p:spPr>
+          <a:xfrm>
+            <a:off x="390727" y="-218534"/>
+            <a:ext cx="10515600" cy="1325563"/>
+          </a:xfrm>
+          <a:prstGeom prst="rect">
+            <a:avLst/>
+          </a:prstGeom>
+        </p:spPr>
+        <p:txBody>
+          <a:bodyPr vert="horz" lIns="91440" tIns="45720" rIns="91440" bIns="45720" rtlCol="0" anchor="ctr">
+            <a:normAutofit/>
+          </a:bodyPr>
+          <a:lstStyle>
+            <a:lvl1pPr algn="l" defTabSz="914400" rtl="0" eaLnBrk="1" latinLnBrk="0" hangingPunct="1">
+              <a:lnSpc>
+                <a:spcPct val="90000"/>
+              </a:lnSpc>
+              <a:spcBef>
+                <a:spcPct val="0"/>
+              </a:spcBef>
+              <a:buNone/>
+              <a:defRPr sz="4400" kern="1200">
+                <a:solidFill>
+                  <a:schemeClr val="tx1"/>
+                </a:solidFill>
+                <a:latin typeface="+mj-lt"/>
+                <a:ea typeface="+mj-ea"/>
+                <a:cs typeface="+mj-cs"/>
+              </a:defRPr>
+            </a:lvl1pPr>
+          </a:lstStyle>
+          <a:p>
+            <a:r>
+              <a:rPr lang="es-ES" b="1" dirty="0">
+                <a:solidFill>
+                  <a:schemeClr val="bg1"/>
+                </a:solidFill>
+              </a:rPr>
+              <a:t>Ejercicio: supuestos y elegir la prueba</a:t>
+            </a:r>
+            <a:endParaRPr lang="es-CO" b="1" dirty="0">
+              <a:solidFill>
+                <a:schemeClr val="bg1"/>
+              </a:solidFill>
+            </a:endParaRPr>
+          </a:p>
+        </p:txBody>
+      </p:sp>
+      <p:sp>
+        <p:nvSpPr>
+          <p:cNvPr id="5" name="CuadroTexto 4"/>
+          <p:cNvSpPr txBox="1"/>
+          <p:nvPr/>
+        </p:nvSpPr>
+        <p:spPr>
+          <a:xfrm>
+            <a:off x="838200" y="1450000"/>
+            <a:ext cx="10515600" cy="5100000"/>
+          </a:xfrm>
+          <a:prstGeom prst="rect">
+            <a:avLst/>
+          </a:prstGeom>
+          <a:noFill/>
+        </p:spPr>
+        <p:txBody>
+          <a:bodyPr wrap="square" lIns="91440" tIns="45720" rIns="91440" bIns="45720" anchor="t">
+            <a:normAutofit/>
+          </a:bodyPr>
+          <a:lstStyle/>
+          <a:p>
+            <a:pPr marL="285750" indent="-285750">
+              <a:lnSpc>
+                <a:spcPct val="115000"/>
+              </a:lnSpc>
+              <a:spcAft>
+                <a:spcPts val="1800"/>
+              </a:spcAft>
+              <a:buFont typeface="Arial"/>
+              <a:buChar char="•"/>
+            </a:pPr>
+            <a:r>
+              <a:rPr lang="es-CO" sz="1700" b="1" dirty="0"/>
+              <a:t>Situación: </a:t>
+            </a:r>
+            <a:r>
+              <a:rPr lang="es-CO" sz="1700" dirty="0"/>
+              <a:t>los dos grupos de curso de preparación tienen variabilidad parecida (desv. est. de 14 a 15 puntos); race/ethnicity tiene 5 grupos distintos.</a:t>
+            </a:r>
+          </a:p>
+          <a:p>
+            <a:pPr marL="285750" indent="-285750">
+              <a:lnSpc>
+                <a:spcPct val="115000"/>
+              </a:lnSpc>
+              <a:spcAft>
+                <a:spcPts val="1800"/>
+              </a:spcAft>
+              <a:buFont typeface="Arial"/>
+              <a:buChar char="•"/>
+            </a:pPr>
+            <a:r>
+              <a:rPr lang="es-CO" sz="1700" b="1" dirty="0"/>
+              <a:t>Pregunta: </a:t>
+            </a:r>
+            <a:r>
+              <a:rPr lang="es-CO" sz="1700" dirty="0"/>
+              <a:t>¿eso describe normalidad u homogeneidad de varianzas? Con 5 grupos, ¿qué herramienta paramétrica usarías (no la prueba t)?</a:t>
+            </a:r>
+          </a:p>
+          <a:p>
+            <a:pPr marL="285750" indent="-285750">
+              <a:lnSpc>
+                <a:spcPct val="115000"/>
+              </a:lnSpc>
+              <a:spcAft>
+                <a:spcPts val="1800"/>
+              </a:spcAft>
+              <a:buFont typeface="Arial"/>
+              <a:buChar char="•"/>
+            </a:pPr>
+            <a:r>
+              <a:rPr lang="es-CO" sz="1700" b="1" dirty="0"/>
+              <a:t>Respuesta: </a:t>
+            </a:r>
+            <a:r>
+              <a:rPr lang="es-CO" sz="1700" i="1" dirty="0"/>
+              <a:t>es homogeneidad de varianzas. Con más de 2 grupos se usa ANOVA (o Kruskal-Wallis si no hay normalidad).</a:t>
+            </a:r>
+          </a:p>
+          <a:p>
+            <a:pPr marL="285750" indent="-285750">
+              <a:lnSpc>
+                <a:spcPct val="115000"/>
+              </a:lnSpc>
+              <a:spcAft>
+                <a:spcPts val="1800"/>
+              </a:spcAft>
+              <a:buFont typeface="Arial"/>
+              <a:buChar char="•"/>
+            </a:pPr>
+            <a:r>
+              <a:rPr lang="es-CO" sz="1700" b="1" dirty="0"/>
+              <a:t>¿Por qué importa?: </a:t>
+            </a:r>
+            <a:r>
+              <a:rPr lang="es-CO" sz="1700" dirty="0"/>
+              <a:t>revisar los supuestos antes de comparar evita usar una herramienta con condiciones que los datos no cumplen.</a:t>
+            </a:r>
+          </a:p>
+        </p:txBody>
+      </p:sp>
+    </p:spTree>
+    <p:extLst>
+      <p:ext uri="{BB962C8B-B14F-4D97-AF65-F5344CB8AC3E}">
+        <p14:creationId xmlns:p14="http://schemas.microsoft.com/office/powerpoint/2010/main" val="1699772436"/>
       </p:ext>
     </p:extLst>
   </p:cSld>

</xml_diff>